<commit_message>
Small poster corrections and improvements
- PDF version added
</commit_message>
<xml_diff>
--- a/Salkicic_Nukic_Halilbasic.pptx
+++ b/Salkicic_Nukic_Halilbasic.pptx
@@ -8975,7 +8975,7 @@
           <a:lstStyle/>
           <a:p>
             <a:r>
-              <a:rPr lang="bs-Latn-BA" sz="2600" b="1" dirty="0">
+              <a:rPr lang="hr-BA" sz="2600" b="1" noProof="1">
                 <a:solidFill>
                   <a:srgbClr val="FFFFFF"/>
                 </a:solidFill>
@@ -8985,7 +8985,7 @@
               </a:rPr>
               <a:t>Airbnb cjenovni obrasci u mediteranskim gradovima</a:t>
             </a:r>
-            <a:endParaRPr lang="en-US" sz="2600" dirty="0"/>
+            <a:endParaRPr lang="hr-BA" sz="2600" noProof="1"/>
           </a:p>
         </p:txBody>
       </p:sp>
@@ -9017,72 +9017,17 @@
           <a:lstStyle/>
           <a:p>
             <a:r>
-              <a:rPr lang="bs-Latn-BA" sz="1000" i="1" dirty="0">
-                <a:solidFill>
-                  <a:srgbClr val="CBD5E1"/>
-                </a:solidFill>
-                <a:latin typeface="Times New Roman" pitchFamily="34" charset="0"/>
-                <a:ea typeface="Times New Roman" pitchFamily="34" charset="-122"/>
-                <a:cs typeface="Times New Roman" pitchFamily="34" charset="-120"/>
-              </a:rPr>
-              <a:t>Ajnur Nukić (ajnur.nukic2002@gmail.com) </a:t>
-            </a:r>
-            <a:r>
-              <a:rPr lang="en-US" sz="1000" i="1" dirty="0">
-                <a:solidFill>
-                  <a:srgbClr val="CBD5E1"/>
-                </a:solidFill>
-                <a:latin typeface="Times New Roman" pitchFamily="34" charset="0"/>
-                <a:ea typeface="Times New Roman" pitchFamily="34" charset="-122"/>
-                <a:cs typeface="Times New Roman" pitchFamily="34" charset="-120"/>
-              </a:rPr>
-              <a:t>|  </a:t>
-            </a:r>
-            <a:r>
-              <a:rPr lang="bs-Latn-BA" sz="1000" i="1" dirty="0">
-                <a:solidFill>
-                  <a:srgbClr val="CBD5E1"/>
-                </a:solidFill>
-                <a:latin typeface="Times New Roman" pitchFamily="34" charset="0"/>
-                <a:ea typeface="Times New Roman" pitchFamily="34" charset="-122"/>
-                <a:cs typeface="Times New Roman" pitchFamily="34" charset="-120"/>
-              </a:rPr>
-              <a:t>Belma Salkičić </a:t>
-            </a:r>
-            <a:r>
-              <a:rPr lang="en-US" sz="1000" i="1" dirty="0">
-                <a:solidFill>
-                  <a:srgbClr val="CBD5E1"/>
-                </a:solidFill>
-                <a:latin typeface="Times New Roman" pitchFamily="34" charset="0"/>
-                <a:ea typeface="Times New Roman" pitchFamily="34" charset="-122"/>
-                <a:cs typeface="Times New Roman" pitchFamily="34" charset="-120"/>
-              </a:rPr>
-              <a:t>(belma7salkicic@gmail.com)  |  </a:t>
-            </a:r>
-            <a:r>
-              <a:rPr lang="bs-Latn-BA" sz="1000" i="1" dirty="0">
-                <a:solidFill>
-                  <a:srgbClr val="CBD5E1"/>
-                </a:solidFill>
-                <a:latin typeface="Times New Roman" pitchFamily="34" charset="0"/>
-                <a:ea typeface="Times New Roman" pitchFamily="34" charset="-122"/>
-                <a:cs typeface="Times New Roman" pitchFamily="34" charset="-120"/>
-              </a:rPr>
-              <a:t>Demir Halilbašić</a:t>
-            </a:r>
-            <a:r>
-              <a:rPr lang="en-US" sz="1000" i="1" dirty="0">
-                <a:solidFill>
-                  <a:srgbClr val="CBD5E1"/>
-                </a:solidFill>
-                <a:latin typeface="Times New Roman" pitchFamily="34" charset="0"/>
-                <a:ea typeface="Times New Roman" pitchFamily="34" charset="-122"/>
-                <a:cs typeface="Times New Roman" pitchFamily="34" charset="-120"/>
-              </a:rPr>
-              <a:t> (demirhalilbasic@gmail.com)</a:t>
-            </a:r>
-            <a:endParaRPr lang="en-US" sz="1000" dirty="0"/>
+              <a:rPr lang="hr-BA" sz="1000" i="1" noProof="1">
+                <a:solidFill>
+                  <a:srgbClr val="CBD5E1"/>
+                </a:solidFill>
+                <a:latin typeface="Times New Roman" pitchFamily="34" charset="0"/>
+                <a:ea typeface="Times New Roman" pitchFamily="34" charset="-122"/>
+                <a:cs typeface="Times New Roman" pitchFamily="34" charset="-120"/>
+              </a:rPr>
+              <a:t>Belma Salkičić (belma7salkicic@gmail.com)  |  Ajnur Nukić (ajnur.nukic2002@gmail.com)  |  Demir Halilbašić (demir.halilbasic@gmail.com)</a:t>
+            </a:r>
+            <a:endParaRPr lang="hr-BA" sz="1000" noProof="1"/>
           </a:p>
         </p:txBody>
       </p:sp>
@@ -9127,7 +9072,7 @@
           <a:bodyPr/>
           <a:lstStyle/>
           <a:p>
-            <a:endParaRPr lang="en-US"/>
+            <a:endParaRPr lang="hr-BA" noProof="1"/>
           </a:p>
         </p:txBody>
       </p:sp>
@@ -9165,7 +9110,7 @@
           <a:bodyPr/>
           <a:lstStyle/>
           <a:p>
-            <a:endParaRPr lang="en-US"/>
+            <a:endParaRPr lang="hr-BA" noProof="1"/>
           </a:p>
         </p:txBody>
       </p:sp>
@@ -9200,7 +9145,7 @@
               <a:buNone/>
             </a:pPr>
             <a:r>
-              <a:rPr lang="en-US" sz="1400" b="1" dirty="0">
+              <a:rPr lang="hr-BA" sz="1400" b="1" noProof="1">
                 <a:solidFill>
                   <a:srgbClr val="0891B2"/>
                 </a:solidFill>
@@ -9210,7 +9155,7 @@
               </a:rPr>
               <a:t>SAŽETAK</a:t>
             </a:r>
-            <a:endParaRPr lang="en-US" sz="1400" dirty="0"/>
+            <a:endParaRPr lang="hr-BA" sz="1400" noProof="1"/>
           </a:p>
         </p:txBody>
       </p:sp>
@@ -9246,7 +9191,7 @@
           <a:bodyPr/>
           <a:lstStyle/>
           <a:p>
-            <a:endParaRPr lang="en-US"/>
+            <a:endParaRPr lang="hr-BA" noProof="1"/>
           </a:p>
         </p:txBody>
       </p:sp>
@@ -9279,86 +9224,12 @@
           <a:p>
             <a:pPr algn="just"/>
             <a:r>
-              <a:rPr lang="bs-Latn-BA" sz="1200" dirty="0">
+              <a:rPr lang="hr-BA" sz="1200" noProof="1">
                 <a:latin typeface="Times New Roman" panose="02020603050405020304" pitchFamily="18" charset="0"/>
                 <a:cs typeface="Times New Roman" panose="02020603050405020304" pitchFamily="18" charset="0"/>
               </a:rPr>
-              <a:t>Istraživanje analizira faktore koji određuju cijenu Airbnb smještaja u </a:t>
-            </a:r>
-            <a:r>
-              <a:rPr lang="en-US" sz="1200" dirty="0" err="1">
-                <a:latin typeface="Times New Roman" panose="02020603050405020304" pitchFamily="18" charset="0"/>
-                <a:cs typeface="Times New Roman" panose="02020603050405020304" pitchFamily="18" charset="0"/>
-              </a:rPr>
-              <a:t>šest</a:t>
-            </a:r>
-            <a:r>
-              <a:rPr lang="en-US" sz="1200" dirty="0">
-                <a:latin typeface="Times New Roman" panose="02020603050405020304" pitchFamily="18" charset="0"/>
-                <a:cs typeface="Times New Roman" panose="02020603050405020304" pitchFamily="18" charset="0"/>
-              </a:rPr>
-              <a:t> </a:t>
-            </a:r>
-            <a:r>
-              <a:rPr lang="en-US" sz="1200" dirty="0" err="1">
-                <a:latin typeface="Times New Roman" panose="02020603050405020304" pitchFamily="18" charset="0"/>
-                <a:cs typeface="Times New Roman" panose="02020603050405020304" pitchFamily="18" charset="0"/>
-              </a:rPr>
-              <a:t>mediteranskih</a:t>
-            </a:r>
-            <a:r>
-              <a:rPr lang="en-US" sz="1200" dirty="0">
-                <a:latin typeface="Times New Roman" panose="02020603050405020304" pitchFamily="18" charset="0"/>
-                <a:cs typeface="Times New Roman" panose="02020603050405020304" pitchFamily="18" charset="0"/>
-              </a:rPr>
-              <a:t> </a:t>
-            </a:r>
-            <a:r>
-              <a:rPr lang="en-US" sz="1200" dirty="0" err="1">
-                <a:latin typeface="Times New Roman" panose="02020603050405020304" pitchFamily="18" charset="0"/>
-                <a:cs typeface="Times New Roman" panose="02020603050405020304" pitchFamily="18" charset="0"/>
-              </a:rPr>
-              <a:t>i</a:t>
-            </a:r>
-            <a:r>
-              <a:rPr lang="en-US" sz="1200" dirty="0">
-                <a:latin typeface="Times New Roman" panose="02020603050405020304" pitchFamily="18" charset="0"/>
-                <a:cs typeface="Times New Roman" panose="02020603050405020304" pitchFamily="18" charset="0"/>
-              </a:rPr>
-              <a:t> </a:t>
-            </a:r>
-            <a:r>
-              <a:rPr lang="en-US" sz="1200" dirty="0" err="1">
-                <a:latin typeface="Times New Roman" panose="02020603050405020304" pitchFamily="18" charset="0"/>
-                <a:cs typeface="Times New Roman" panose="02020603050405020304" pitchFamily="18" charset="0"/>
-              </a:rPr>
-              <a:t>južnoevropskih</a:t>
-            </a:r>
-            <a:r>
-              <a:rPr lang="en-US" sz="1200" dirty="0">
-                <a:latin typeface="Times New Roman" panose="02020603050405020304" pitchFamily="18" charset="0"/>
-                <a:cs typeface="Times New Roman" panose="02020603050405020304" pitchFamily="18" charset="0"/>
-              </a:rPr>
-              <a:t> </a:t>
-            </a:r>
-            <a:r>
-              <a:rPr lang="en-US" sz="1200" dirty="0" err="1">
-                <a:latin typeface="Times New Roman" panose="02020603050405020304" pitchFamily="18" charset="0"/>
-                <a:cs typeface="Times New Roman" panose="02020603050405020304" pitchFamily="18" charset="0"/>
-              </a:rPr>
-              <a:t>gradova</a:t>
-            </a:r>
-            <a:r>
-              <a:rPr lang="bs-Latn-BA" sz="1200" dirty="0">
-                <a:latin typeface="Times New Roman" panose="02020603050405020304" pitchFamily="18" charset="0"/>
-                <a:cs typeface="Times New Roman" panose="02020603050405020304" pitchFamily="18" charset="0"/>
-              </a:rPr>
-              <a:t>. Analiza je provedena na uzorku od 91.301 oglasa. Primijenjeni su regresijski modeli, geospacijalna analiza i klasterizacija. Tip smještaja pokazao se kao dominantniji cjenovni faktor od lokacije u pet od šest gradova. Rim je najskuplje tržište, a Atena i Istanbul nude najbolji omjer cijene i kvalitete.</a:t>
-            </a:r>
-            <a:endParaRPr lang="en-US" sz="1200" dirty="0">
-              <a:latin typeface="Times New Roman" panose="02020603050405020304" pitchFamily="18" charset="0"/>
-              <a:cs typeface="Times New Roman" panose="02020603050405020304" pitchFamily="18" charset="0"/>
-            </a:endParaRPr>
+              <a:t>Istraživanje analizira faktore koji određuju cijenu Airbnb smještaja u šest mediteranskih i južnoevropskih gradova. Analiza je provedena na uzorku od 91.301 oglasa. Primijenjeni su regresijski modeli, geospacijalna analiza i klasterizacija. Tip smještaja pokazao se kao dominantniji cjenovni faktor od lokacije u pet od šest gradova. Rim je najskuplje tržište, dok Atena i Istanbul nude najbolji omjer cijene i kvalitete.</a:t>
+            </a:r>
           </a:p>
         </p:txBody>
       </p:sp>
@@ -9403,7 +9274,7 @@
           <a:bodyPr/>
           <a:lstStyle/>
           <a:p>
-            <a:endParaRPr lang="en-US"/>
+            <a:endParaRPr lang="hr-BA" noProof="1"/>
           </a:p>
         </p:txBody>
       </p:sp>
@@ -9441,7 +9312,7 @@
           <a:bodyPr/>
           <a:lstStyle/>
           <a:p>
-            <a:endParaRPr lang="en-US"/>
+            <a:endParaRPr lang="hr-BA" noProof="1"/>
           </a:p>
         </p:txBody>
       </p:sp>
@@ -9476,7 +9347,7 @@
               <a:buNone/>
             </a:pPr>
             <a:r>
-              <a:rPr lang="en-US" sz="1400" b="1" dirty="0">
+              <a:rPr lang="hr-BA" sz="1400" b="1" noProof="1">
                 <a:solidFill>
                   <a:srgbClr val="0891B2"/>
                 </a:solidFill>
@@ -9486,7 +9357,7 @@
               </a:rPr>
               <a:t>UVOD I ISTRAŽIVAČKO PITANJE</a:t>
             </a:r>
-            <a:endParaRPr lang="en-US" sz="1400" dirty="0"/>
+            <a:endParaRPr lang="hr-BA" sz="1400" noProof="1"/>
           </a:p>
         </p:txBody>
       </p:sp>
@@ -9522,7 +9393,7 @@
           <a:bodyPr/>
           <a:lstStyle/>
           <a:p>
-            <a:endParaRPr lang="en-US"/>
+            <a:endParaRPr lang="hr-BA" noProof="1"/>
           </a:p>
         </p:txBody>
       </p:sp>
@@ -9555,7 +9426,7 @@
           <a:p>
             <a:pPr algn="just"/>
             <a:r>
-              <a:rPr lang="bs-Latn-BA" sz="1200" dirty="0">
+              <a:rPr lang="hr-BA" sz="1200" noProof="1">
                 <a:latin typeface="Times New Roman" panose="02020603050405020304" pitchFamily="18" charset="0"/>
                 <a:cs typeface="Times New Roman" panose="02020603050405020304" pitchFamily="18" charset="0"/>
               </a:rPr>
@@ -9564,7 +9435,7 @@
           </a:p>
           <a:p>
             <a:pPr algn="just"/>
-            <a:endParaRPr lang="bs-Latn-BA" sz="1200" dirty="0">
+            <a:endParaRPr lang="hr-BA" sz="1200" noProof="1">
               <a:latin typeface="Times New Roman" panose="02020603050405020304" pitchFamily="18" charset="0"/>
               <a:cs typeface="Times New Roman" panose="02020603050405020304" pitchFamily="18" charset="0"/>
             </a:endParaRPr>
@@ -9572,762 +9443,33 @@
           <a:p>
             <a:pPr algn="just"/>
             <a:r>
-              <a:rPr lang="en-US" sz="1200" dirty="0">
+              <a:rPr lang="hr-BA" sz="1200" noProof="1">
                 <a:latin typeface="Times New Roman" panose="02020603050405020304" pitchFamily="18" charset="0"/>
                 <a:cs typeface="Times New Roman" panose="02020603050405020304" pitchFamily="18" charset="0"/>
               </a:rPr>
-              <a:t>Ovo </a:t>
-            </a:r>
-            <a:r>
-              <a:rPr lang="en-US" sz="1200" dirty="0" err="1">
-                <a:latin typeface="Times New Roman" panose="02020603050405020304" pitchFamily="18" charset="0"/>
-                <a:cs typeface="Times New Roman" panose="02020603050405020304" pitchFamily="18" charset="0"/>
-              </a:rPr>
-              <a:t>istraživanje</a:t>
-            </a:r>
-            <a:r>
-              <a:rPr lang="en-US" sz="1200" dirty="0">
-                <a:latin typeface="Times New Roman" panose="02020603050405020304" pitchFamily="18" charset="0"/>
-                <a:cs typeface="Times New Roman" panose="02020603050405020304" pitchFamily="18" charset="0"/>
-              </a:rPr>
-              <a:t> </a:t>
-            </a:r>
-            <a:r>
-              <a:rPr lang="en-US" sz="1200" dirty="0" err="1">
-                <a:latin typeface="Times New Roman" panose="02020603050405020304" pitchFamily="18" charset="0"/>
-                <a:cs typeface="Times New Roman" panose="02020603050405020304" pitchFamily="18" charset="0"/>
-              </a:rPr>
-              <a:t>analizira</a:t>
-            </a:r>
-            <a:r>
-              <a:rPr lang="en-US" sz="1200" dirty="0">
-                <a:latin typeface="Times New Roman" panose="02020603050405020304" pitchFamily="18" charset="0"/>
-                <a:cs typeface="Times New Roman" panose="02020603050405020304" pitchFamily="18" charset="0"/>
-              </a:rPr>
-              <a:t> </a:t>
-            </a:r>
-            <a:r>
-              <a:rPr lang="en-US" sz="1200" dirty="0" err="1">
-                <a:latin typeface="Times New Roman" panose="02020603050405020304" pitchFamily="18" charset="0"/>
-                <a:cs typeface="Times New Roman" panose="02020603050405020304" pitchFamily="18" charset="0"/>
-              </a:rPr>
-              <a:t>obrasce</a:t>
-            </a:r>
-            <a:r>
-              <a:rPr lang="en-US" sz="1200" dirty="0">
-                <a:latin typeface="Times New Roman" panose="02020603050405020304" pitchFamily="18" charset="0"/>
-                <a:cs typeface="Times New Roman" panose="02020603050405020304" pitchFamily="18" charset="0"/>
-              </a:rPr>
-              <a:t> </a:t>
-            </a:r>
-            <a:r>
-              <a:rPr lang="en-US" sz="1200" dirty="0" err="1">
-                <a:latin typeface="Times New Roman" panose="02020603050405020304" pitchFamily="18" charset="0"/>
-                <a:cs typeface="Times New Roman" panose="02020603050405020304" pitchFamily="18" charset="0"/>
-              </a:rPr>
-              <a:t>formiranja</a:t>
-            </a:r>
-            <a:r>
-              <a:rPr lang="en-US" sz="1200" dirty="0">
-                <a:latin typeface="Times New Roman" panose="02020603050405020304" pitchFamily="18" charset="0"/>
-                <a:cs typeface="Times New Roman" panose="02020603050405020304" pitchFamily="18" charset="0"/>
-              </a:rPr>
-              <a:t> </a:t>
-            </a:r>
-            <a:r>
-              <a:rPr lang="en-US" sz="1200" dirty="0" err="1">
-                <a:latin typeface="Times New Roman" panose="02020603050405020304" pitchFamily="18" charset="0"/>
-                <a:cs typeface="Times New Roman" panose="02020603050405020304" pitchFamily="18" charset="0"/>
-              </a:rPr>
-              <a:t>cijena</a:t>
-            </a:r>
-            <a:r>
-              <a:rPr lang="en-US" sz="1200" dirty="0">
-                <a:latin typeface="Times New Roman" panose="02020603050405020304" pitchFamily="18" charset="0"/>
-                <a:cs typeface="Times New Roman" panose="02020603050405020304" pitchFamily="18" charset="0"/>
-              </a:rPr>
-              <a:t> Airbnb </a:t>
-            </a:r>
-            <a:r>
-              <a:rPr lang="en-US" sz="1200" dirty="0" err="1">
-                <a:latin typeface="Times New Roman" panose="02020603050405020304" pitchFamily="18" charset="0"/>
-                <a:cs typeface="Times New Roman" panose="02020603050405020304" pitchFamily="18" charset="0"/>
-              </a:rPr>
-              <a:t>smještaja</a:t>
-            </a:r>
-            <a:r>
-              <a:rPr lang="en-US" sz="1200" dirty="0">
-                <a:latin typeface="Times New Roman" panose="02020603050405020304" pitchFamily="18" charset="0"/>
-                <a:cs typeface="Times New Roman" panose="02020603050405020304" pitchFamily="18" charset="0"/>
-              </a:rPr>
-              <a:t> u </a:t>
-            </a:r>
-            <a:r>
-              <a:rPr lang="en-US" sz="1200" dirty="0" err="1">
-                <a:latin typeface="Times New Roman" panose="02020603050405020304" pitchFamily="18" charset="0"/>
-                <a:cs typeface="Times New Roman" panose="02020603050405020304" pitchFamily="18" charset="0"/>
-              </a:rPr>
-              <a:t>šest</a:t>
-            </a:r>
-            <a:r>
-              <a:rPr lang="en-US" sz="1200" dirty="0">
-                <a:latin typeface="Times New Roman" panose="02020603050405020304" pitchFamily="18" charset="0"/>
-                <a:cs typeface="Times New Roman" panose="02020603050405020304" pitchFamily="18" charset="0"/>
-              </a:rPr>
-              <a:t> </a:t>
-            </a:r>
-            <a:r>
-              <a:rPr lang="en-US" sz="1200" dirty="0" err="1">
-                <a:latin typeface="Times New Roman" panose="02020603050405020304" pitchFamily="18" charset="0"/>
-                <a:cs typeface="Times New Roman" panose="02020603050405020304" pitchFamily="18" charset="0"/>
-              </a:rPr>
-              <a:t>mediteranskih</a:t>
-            </a:r>
-            <a:r>
-              <a:rPr lang="en-US" sz="1200" dirty="0">
-                <a:latin typeface="Times New Roman" panose="02020603050405020304" pitchFamily="18" charset="0"/>
-                <a:cs typeface="Times New Roman" panose="02020603050405020304" pitchFamily="18" charset="0"/>
-              </a:rPr>
-              <a:t> </a:t>
-            </a:r>
-            <a:r>
-              <a:rPr lang="en-US" sz="1200" dirty="0" err="1">
-                <a:latin typeface="Times New Roman" panose="02020603050405020304" pitchFamily="18" charset="0"/>
-                <a:cs typeface="Times New Roman" panose="02020603050405020304" pitchFamily="18" charset="0"/>
-              </a:rPr>
-              <a:t>i</a:t>
-            </a:r>
-            <a:r>
-              <a:rPr lang="en-US" sz="1200" dirty="0">
-                <a:latin typeface="Times New Roman" panose="02020603050405020304" pitchFamily="18" charset="0"/>
-                <a:cs typeface="Times New Roman" panose="02020603050405020304" pitchFamily="18" charset="0"/>
-              </a:rPr>
-              <a:t> </a:t>
-            </a:r>
-            <a:r>
-              <a:rPr lang="en-US" sz="1200" dirty="0" err="1">
-                <a:latin typeface="Times New Roman" panose="02020603050405020304" pitchFamily="18" charset="0"/>
-                <a:cs typeface="Times New Roman" panose="02020603050405020304" pitchFamily="18" charset="0"/>
-              </a:rPr>
-              <a:t>južnoevropskih</a:t>
-            </a:r>
-            <a:r>
-              <a:rPr lang="en-US" sz="1200" dirty="0">
-                <a:latin typeface="Times New Roman" panose="02020603050405020304" pitchFamily="18" charset="0"/>
-                <a:cs typeface="Times New Roman" panose="02020603050405020304" pitchFamily="18" charset="0"/>
-              </a:rPr>
-              <a:t> </a:t>
-            </a:r>
-            <a:r>
-              <a:rPr lang="en-US" sz="1200" dirty="0" err="1">
-                <a:latin typeface="Times New Roman" panose="02020603050405020304" pitchFamily="18" charset="0"/>
-                <a:cs typeface="Times New Roman" panose="02020603050405020304" pitchFamily="18" charset="0"/>
-              </a:rPr>
-              <a:t>gradova</a:t>
-            </a:r>
-            <a:r>
-              <a:rPr lang="en-US" sz="1200" dirty="0">
-                <a:latin typeface="Times New Roman" panose="02020603050405020304" pitchFamily="18" charset="0"/>
-                <a:cs typeface="Times New Roman" panose="02020603050405020304" pitchFamily="18" charset="0"/>
-              </a:rPr>
-              <a:t>: </a:t>
-            </a:r>
-            <a:r>
-              <a:rPr lang="en-US" sz="1200" dirty="0" err="1">
-                <a:latin typeface="Times New Roman" panose="02020603050405020304" pitchFamily="18" charset="0"/>
-                <a:cs typeface="Times New Roman" panose="02020603050405020304" pitchFamily="18" charset="0"/>
-              </a:rPr>
-              <a:t>Ateni</a:t>
-            </a:r>
-            <a:r>
-              <a:rPr lang="en-US" sz="1200" dirty="0">
-                <a:latin typeface="Times New Roman" panose="02020603050405020304" pitchFamily="18" charset="0"/>
-                <a:cs typeface="Times New Roman" panose="02020603050405020304" pitchFamily="18" charset="0"/>
-              </a:rPr>
-              <a:t>, </a:t>
-            </a:r>
-            <a:r>
-              <a:rPr lang="en-US" sz="1200" dirty="0" err="1">
-                <a:latin typeface="Times New Roman" panose="02020603050405020304" pitchFamily="18" charset="0"/>
-                <a:cs typeface="Times New Roman" panose="02020603050405020304" pitchFamily="18" charset="0"/>
-              </a:rPr>
-              <a:t>Malagi</a:t>
-            </a:r>
-            <a:r>
-              <a:rPr lang="en-US" sz="1200" dirty="0">
-                <a:latin typeface="Times New Roman" panose="02020603050405020304" pitchFamily="18" charset="0"/>
-                <a:cs typeface="Times New Roman" panose="02020603050405020304" pitchFamily="18" charset="0"/>
-              </a:rPr>
-              <a:t>, </a:t>
-            </a:r>
-            <a:r>
-              <a:rPr lang="en-US" sz="1200" dirty="0" err="1">
-                <a:latin typeface="Times New Roman" panose="02020603050405020304" pitchFamily="18" charset="0"/>
-                <a:cs typeface="Times New Roman" panose="02020603050405020304" pitchFamily="18" charset="0"/>
-              </a:rPr>
-              <a:t>Istanbulu</a:t>
-            </a:r>
-            <a:r>
-              <a:rPr lang="en-US" sz="1200" dirty="0">
-                <a:latin typeface="Times New Roman" panose="02020603050405020304" pitchFamily="18" charset="0"/>
-                <a:cs typeface="Times New Roman" panose="02020603050405020304" pitchFamily="18" charset="0"/>
-              </a:rPr>
-              <a:t>, </a:t>
-            </a:r>
-            <a:r>
-              <a:rPr lang="en-US" sz="1200" dirty="0" err="1">
-                <a:latin typeface="Times New Roman" panose="02020603050405020304" pitchFamily="18" charset="0"/>
-                <a:cs typeface="Times New Roman" panose="02020603050405020304" pitchFamily="18" charset="0"/>
-              </a:rPr>
-              <a:t>Napulju</a:t>
-            </a:r>
-            <a:r>
-              <a:rPr lang="en-US" sz="1200" dirty="0">
-                <a:latin typeface="Times New Roman" panose="02020603050405020304" pitchFamily="18" charset="0"/>
-                <a:cs typeface="Times New Roman" panose="02020603050405020304" pitchFamily="18" charset="0"/>
-              </a:rPr>
-              <a:t>, Rimu </a:t>
-            </a:r>
-            <a:r>
-              <a:rPr lang="en-US" sz="1200" dirty="0" err="1">
-                <a:latin typeface="Times New Roman" panose="02020603050405020304" pitchFamily="18" charset="0"/>
-                <a:cs typeface="Times New Roman" panose="02020603050405020304" pitchFamily="18" charset="0"/>
-              </a:rPr>
-              <a:t>i</a:t>
-            </a:r>
-            <a:r>
-              <a:rPr lang="en-US" sz="1200" dirty="0">
-                <a:latin typeface="Times New Roman" panose="02020603050405020304" pitchFamily="18" charset="0"/>
-                <a:cs typeface="Times New Roman" panose="02020603050405020304" pitchFamily="18" charset="0"/>
-              </a:rPr>
-              <a:t> </a:t>
-            </a:r>
-            <a:r>
-              <a:rPr lang="en-US" sz="1200" dirty="0" err="1">
-                <a:latin typeface="Times New Roman" panose="02020603050405020304" pitchFamily="18" charset="0"/>
-                <a:cs typeface="Times New Roman" panose="02020603050405020304" pitchFamily="18" charset="0"/>
-              </a:rPr>
-              <a:t>Valenciji</a:t>
-            </a:r>
-            <a:r>
-              <a:rPr lang="en-US" sz="1200" dirty="0">
-                <a:latin typeface="Times New Roman" panose="02020603050405020304" pitchFamily="18" charset="0"/>
-                <a:cs typeface="Times New Roman" panose="02020603050405020304" pitchFamily="18" charset="0"/>
-              </a:rPr>
-              <a:t>. </a:t>
-            </a:r>
-            <a:r>
-              <a:rPr lang="en-US" sz="1200" dirty="0" err="1">
-                <a:latin typeface="Times New Roman" panose="02020603050405020304" pitchFamily="18" charset="0"/>
-                <a:cs typeface="Times New Roman" panose="02020603050405020304" pitchFamily="18" charset="0"/>
-              </a:rPr>
-              <a:t>Fokus</a:t>
-            </a:r>
-            <a:r>
-              <a:rPr lang="en-US" sz="1200" dirty="0">
-                <a:latin typeface="Times New Roman" panose="02020603050405020304" pitchFamily="18" charset="0"/>
-                <a:cs typeface="Times New Roman" panose="02020603050405020304" pitchFamily="18" charset="0"/>
-              </a:rPr>
-              <a:t> je </a:t>
-            </a:r>
-            <a:r>
-              <a:rPr lang="en-US" sz="1200" dirty="0" err="1">
-                <a:latin typeface="Times New Roman" panose="02020603050405020304" pitchFamily="18" charset="0"/>
-                <a:cs typeface="Times New Roman" panose="02020603050405020304" pitchFamily="18" charset="0"/>
-              </a:rPr>
-              <a:t>na</a:t>
-            </a:r>
-            <a:r>
-              <a:rPr lang="en-US" sz="1200" dirty="0">
-                <a:latin typeface="Times New Roman" panose="02020603050405020304" pitchFamily="18" charset="0"/>
-                <a:cs typeface="Times New Roman" panose="02020603050405020304" pitchFamily="18" charset="0"/>
-              </a:rPr>
-              <a:t> </a:t>
-            </a:r>
-            <a:r>
-              <a:rPr lang="en-US" sz="1200" dirty="0" err="1">
-                <a:latin typeface="Times New Roman" panose="02020603050405020304" pitchFamily="18" charset="0"/>
-                <a:cs typeface="Times New Roman" panose="02020603050405020304" pitchFamily="18" charset="0"/>
-              </a:rPr>
-              <a:t>dva</a:t>
-            </a:r>
-            <a:r>
-              <a:rPr lang="en-US" sz="1200" dirty="0">
-                <a:latin typeface="Times New Roman" panose="02020603050405020304" pitchFamily="18" charset="0"/>
-                <a:cs typeface="Times New Roman" panose="02020603050405020304" pitchFamily="18" charset="0"/>
-              </a:rPr>
-              <a:t> </a:t>
-            </a:r>
-            <a:r>
-              <a:rPr lang="en-US" sz="1200" dirty="0" err="1">
-                <a:latin typeface="Times New Roman" panose="02020603050405020304" pitchFamily="18" charset="0"/>
-                <a:cs typeface="Times New Roman" panose="02020603050405020304" pitchFamily="18" charset="0"/>
-              </a:rPr>
-              <a:t>ključna</a:t>
-            </a:r>
-            <a:r>
-              <a:rPr lang="en-US" sz="1200" dirty="0">
-                <a:latin typeface="Times New Roman" panose="02020603050405020304" pitchFamily="18" charset="0"/>
-                <a:cs typeface="Times New Roman" panose="02020603050405020304" pitchFamily="18" charset="0"/>
-              </a:rPr>
-              <a:t> </a:t>
-            </a:r>
-            <a:r>
-              <a:rPr lang="en-US" sz="1200" dirty="0" err="1">
-                <a:latin typeface="Times New Roman" panose="02020603050405020304" pitchFamily="18" charset="0"/>
-                <a:cs typeface="Times New Roman" panose="02020603050405020304" pitchFamily="18" charset="0"/>
-              </a:rPr>
-              <a:t>faktora</a:t>
-            </a:r>
-            <a:r>
-              <a:rPr lang="bs-Latn-BA" sz="1200" dirty="0">
-                <a:latin typeface="Times New Roman" panose="02020603050405020304" pitchFamily="18" charset="0"/>
-                <a:cs typeface="Times New Roman" panose="02020603050405020304" pitchFamily="18" charset="0"/>
-              </a:rPr>
-              <a:t> - </a:t>
-            </a:r>
-            <a:r>
-              <a:rPr lang="en-US" sz="1200" dirty="0" err="1">
-                <a:latin typeface="Times New Roman" panose="02020603050405020304" pitchFamily="18" charset="0"/>
-                <a:cs typeface="Times New Roman" panose="02020603050405020304" pitchFamily="18" charset="0"/>
-              </a:rPr>
-              <a:t>geografskoj</a:t>
-            </a:r>
-            <a:r>
-              <a:rPr lang="en-US" sz="1200" dirty="0">
-                <a:latin typeface="Times New Roman" panose="02020603050405020304" pitchFamily="18" charset="0"/>
-                <a:cs typeface="Times New Roman" panose="02020603050405020304" pitchFamily="18" charset="0"/>
-              </a:rPr>
-              <a:t> </a:t>
-            </a:r>
-            <a:r>
-              <a:rPr lang="en-US" sz="1200" dirty="0" err="1">
-                <a:latin typeface="Times New Roman" panose="02020603050405020304" pitchFamily="18" charset="0"/>
-                <a:cs typeface="Times New Roman" panose="02020603050405020304" pitchFamily="18" charset="0"/>
-              </a:rPr>
-              <a:t>lokaciji</a:t>
-            </a:r>
-            <a:r>
-              <a:rPr lang="en-US" sz="1200" dirty="0">
-                <a:latin typeface="Times New Roman" panose="02020603050405020304" pitchFamily="18" charset="0"/>
-                <a:cs typeface="Times New Roman" panose="02020603050405020304" pitchFamily="18" charset="0"/>
-              </a:rPr>
-              <a:t> </a:t>
-            </a:r>
-            <a:r>
-              <a:rPr lang="en-US" sz="1200" dirty="0" err="1">
-                <a:latin typeface="Times New Roman" panose="02020603050405020304" pitchFamily="18" charset="0"/>
-                <a:cs typeface="Times New Roman" panose="02020603050405020304" pitchFamily="18" charset="0"/>
-              </a:rPr>
-              <a:t>smještaja</a:t>
-            </a:r>
-            <a:r>
-              <a:rPr lang="en-US" sz="1200" dirty="0">
-                <a:latin typeface="Times New Roman" panose="02020603050405020304" pitchFamily="18" charset="0"/>
-                <a:cs typeface="Times New Roman" panose="02020603050405020304" pitchFamily="18" charset="0"/>
-              </a:rPr>
-              <a:t> (</a:t>
-            </a:r>
-            <a:r>
-              <a:rPr lang="en-US" sz="1200" dirty="0" err="1">
-                <a:latin typeface="Times New Roman" panose="02020603050405020304" pitchFamily="18" charset="0"/>
-                <a:cs typeface="Times New Roman" panose="02020603050405020304" pitchFamily="18" charset="0"/>
-              </a:rPr>
-              <a:t>centar</a:t>
-            </a:r>
-            <a:r>
-              <a:rPr lang="en-US" sz="1200" dirty="0">
-                <a:latin typeface="Times New Roman" panose="02020603050405020304" pitchFamily="18" charset="0"/>
-                <a:cs typeface="Times New Roman" panose="02020603050405020304" pitchFamily="18" charset="0"/>
-              </a:rPr>
-              <a:t> </a:t>
-            </a:r>
-            <a:r>
-              <a:rPr lang="en-US" sz="1200" dirty="0" err="1">
-                <a:latin typeface="Times New Roman" panose="02020603050405020304" pitchFamily="18" charset="0"/>
-                <a:cs typeface="Times New Roman" panose="02020603050405020304" pitchFamily="18" charset="0"/>
-              </a:rPr>
-              <a:t>naspram</a:t>
-            </a:r>
-            <a:r>
-              <a:rPr lang="en-US" sz="1200" dirty="0">
-                <a:latin typeface="Times New Roman" panose="02020603050405020304" pitchFamily="18" charset="0"/>
-                <a:cs typeface="Times New Roman" panose="02020603050405020304" pitchFamily="18" charset="0"/>
-              </a:rPr>
-              <a:t> </a:t>
-            </a:r>
-            <a:r>
-              <a:rPr lang="en-US" sz="1200" dirty="0" err="1">
-                <a:latin typeface="Times New Roman" panose="02020603050405020304" pitchFamily="18" charset="0"/>
-                <a:cs typeface="Times New Roman" panose="02020603050405020304" pitchFamily="18" charset="0"/>
-              </a:rPr>
-              <a:t>periferije</a:t>
-            </a:r>
-            <a:r>
-              <a:rPr lang="en-US" sz="1200" dirty="0">
-                <a:latin typeface="Times New Roman" panose="02020603050405020304" pitchFamily="18" charset="0"/>
-                <a:cs typeface="Times New Roman" panose="02020603050405020304" pitchFamily="18" charset="0"/>
-              </a:rPr>
-              <a:t>) </a:t>
-            </a:r>
-            <a:r>
-              <a:rPr lang="en-US" sz="1200" dirty="0" err="1">
-                <a:latin typeface="Times New Roman" panose="02020603050405020304" pitchFamily="18" charset="0"/>
-                <a:cs typeface="Times New Roman" panose="02020603050405020304" pitchFamily="18" charset="0"/>
-              </a:rPr>
-              <a:t>i</a:t>
-            </a:r>
-            <a:r>
-              <a:rPr lang="en-US" sz="1200" dirty="0">
-                <a:latin typeface="Times New Roman" panose="02020603050405020304" pitchFamily="18" charset="0"/>
-                <a:cs typeface="Times New Roman" panose="02020603050405020304" pitchFamily="18" charset="0"/>
-              </a:rPr>
-              <a:t> </a:t>
-            </a:r>
-            <a:r>
-              <a:rPr lang="en-US" sz="1200" dirty="0" err="1">
-                <a:latin typeface="Times New Roman" panose="02020603050405020304" pitchFamily="18" charset="0"/>
-                <a:cs typeface="Times New Roman" panose="02020603050405020304" pitchFamily="18" charset="0"/>
-              </a:rPr>
-              <a:t>tipu</a:t>
-            </a:r>
-            <a:r>
-              <a:rPr lang="en-US" sz="1200" dirty="0">
-                <a:latin typeface="Times New Roman" panose="02020603050405020304" pitchFamily="18" charset="0"/>
-                <a:cs typeface="Times New Roman" panose="02020603050405020304" pitchFamily="18" charset="0"/>
-              </a:rPr>
-              <a:t> </a:t>
-            </a:r>
-            <a:r>
-              <a:rPr lang="en-US" sz="1200" dirty="0" err="1">
-                <a:latin typeface="Times New Roman" panose="02020603050405020304" pitchFamily="18" charset="0"/>
-                <a:cs typeface="Times New Roman" panose="02020603050405020304" pitchFamily="18" charset="0"/>
-              </a:rPr>
-              <a:t>smještaja</a:t>
-            </a:r>
-            <a:r>
-              <a:rPr lang="en-US" sz="1200" dirty="0">
-                <a:latin typeface="Times New Roman" panose="02020603050405020304" pitchFamily="18" charset="0"/>
-                <a:cs typeface="Times New Roman" panose="02020603050405020304" pitchFamily="18" charset="0"/>
-              </a:rPr>
-              <a:t> (</a:t>
-            </a:r>
-            <a:r>
-              <a:rPr lang="en-US" sz="1200" dirty="0" err="1">
-                <a:latin typeface="Times New Roman" panose="02020603050405020304" pitchFamily="18" charset="0"/>
-                <a:cs typeface="Times New Roman" panose="02020603050405020304" pitchFamily="18" charset="0"/>
-              </a:rPr>
-              <a:t>cijeli</a:t>
-            </a:r>
-            <a:r>
-              <a:rPr lang="en-US" sz="1200" dirty="0">
-                <a:latin typeface="Times New Roman" panose="02020603050405020304" pitchFamily="18" charset="0"/>
-                <a:cs typeface="Times New Roman" panose="02020603050405020304" pitchFamily="18" charset="0"/>
-              </a:rPr>
-              <a:t> stan/</a:t>
-            </a:r>
-            <a:r>
-              <a:rPr lang="en-US" sz="1200" dirty="0" err="1">
-                <a:latin typeface="Times New Roman" panose="02020603050405020304" pitchFamily="18" charset="0"/>
-                <a:cs typeface="Times New Roman" panose="02020603050405020304" pitchFamily="18" charset="0"/>
-              </a:rPr>
-              <a:t>kuća</a:t>
-            </a:r>
-            <a:r>
-              <a:rPr lang="en-US" sz="1200" dirty="0">
-                <a:latin typeface="Times New Roman" panose="02020603050405020304" pitchFamily="18" charset="0"/>
-                <a:cs typeface="Times New Roman" panose="02020603050405020304" pitchFamily="18" charset="0"/>
-              </a:rPr>
-              <a:t>, </a:t>
-            </a:r>
-            <a:r>
-              <a:rPr lang="en-US" sz="1200" dirty="0" err="1">
-                <a:latin typeface="Times New Roman" panose="02020603050405020304" pitchFamily="18" charset="0"/>
-                <a:cs typeface="Times New Roman" panose="02020603050405020304" pitchFamily="18" charset="0"/>
-              </a:rPr>
-              <a:t>privatna</a:t>
-            </a:r>
-            <a:r>
-              <a:rPr lang="en-US" sz="1200" dirty="0">
-                <a:latin typeface="Times New Roman" panose="02020603050405020304" pitchFamily="18" charset="0"/>
-                <a:cs typeface="Times New Roman" panose="02020603050405020304" pitchFamily="18" charset="0"/>
-              </a:rPr>
-              <a:t> soba </a:t>
-            </a:r>
-            <a:r>
-              <a:rPr lang="en-US" sz="1200" dirty="0" err="1">
-                <a:latin typeface="Times New Roman" panose="02020603050405020304" pitchFamily="18" charset="0"/>
-                <a:cs typeface="Times New Roman" panose="02020603050405020304" pitchFamily="18" charset="0"/>
-              </a:rPr>
-              <a:t>i</a:t>
-            </a:r>
-            <a:r>
-              <a:rPr lang="en-US" sz="1200" dirty="0">
-                <a:latin typeface="Times New Roman" panose="02020603050405020304" pitchFamily="18" charset="0"/>
-                <a:cs typeface="Times New Roman" panose="02020603050405020304" pitchFamily="18" charset="0"/>
-              </a:rPr>
-              <a:t> </a:t>
-            </a:r>
-            <a:r>
-              <a:rPr lang="en-US" sz="1200" dirty="0" err="1">
-                <a:latin typeface="Times New Roman" panose="02020603050405020304" pitchFamily="18" charset="0"/>
-                <a:cs typeface="Times New Roman" panose="02020603050405020304" pitchFamily="18" charset="0"/>
-              </a:rPr>
-              <a:t>zajednička</a:t>
-            </a:r>
-            <a:r>
-              <a:rPr lang="en-US" sz="1200" dirty="0">
-                <a:latin typeface="Times New Roman" panose="02020603050405020304" pitchFamily="18" charset="0"/>
-                <a:cs typeface="Times New Roman" panose="02020603050405020304" pitchFamily="18" charset="0"/>
-              </a:rPr>
-              <a:t> soba). </a:t>
-            </a:r>
-            <a:r>
-              <a:rPr lang="en-US" sz="1200" dirty="0" err="1">
-                <a:latin typeface="Times New Roman" panose="02020603050405020304" pitchFamily="18" charset="0"/>
-                <a:cs typeface="Times New Roman" panose="02020603050405020304" pitchFamily="18" charset="0"/>
-              </a:rPr>
-              <a:t>Cilj</a:t>
-            </a:r>
-            <a:r>
-              <a:rPr lang="en-US" sz="1200" dirty="0">
-                <a:latin typeface="Times New Roman" panose="02020603050405020304" pitchFamily="18" charset="0"/>
-                <a:cs typeface="Times New Roman" panose="02020603050405020304" pitchFamily="18" charset="0"/>
-              </a:rPr>
-              <a:t> rada je </a:t>
-            </a:r>
-            <a:r>
-              <a:rPr lang="en-US" sz="1200" dirty="0" err="1">
-                <a:latin typeface="Times New Roman" panose="02020603050405020304" pitchFamily="18" charset="0"/>
-                <a:cs typeface="Times New Roman" panose="02020603050405020304" pitchFamily="18" charset="0"/>
-              </a:rPr>
-              <a:t>utvrditi</a:t>
-            </a:r>
-            <a:r>
-              <a:rPr lang="en-US" sz="1200" dirty="0">
-                <a:latin typeface="Times New Roman" panose="02020603050405020304" pitchFamily="18" charset="0"/>
-                <a:cs typeface="Times New Roman" panose="02020603050405020304" pitchFamily="18" charset="0"/>
-              </a:rPr>
-              <a:t> </a:t>
-            </a:r>
-            <a:r>
-              <a:rPr lang="en-US" sz="1200" dirty="0" err="1">
-                <a:latin typeface="Times New Roman" panose="02020603050405020304" pitchFamily="18" charset="0"/>
-                <a:cs typeface="Times New Roman" panose="02020603050405020304" pitchFamily="18" charset="0"/>
-              </a:rPr>
-              <a:t>djeluju</a:t>
-            </a:r>
-            <a:r>
-              <a:rPr lang="en-US" sz="1200" dirty="0">
-                <a:latin typeface="Times New Roman" panose="02020603050405020304" pitchFamily="18" charset="0"/>
-                <a:cs typeface="Times New Roman" panose="02020603050405020304" pitchFamily="18" charset="0"/>
-              </a:rPr>
-              <a:t> li </a:t>
-            </a:r>
-            <a:r>
-              <a:rPr lang="en-US" sz="1200" dirty="0" err="1">
-                <a:latin typeface="Times New Roman" panose="02020603050405020304" pitchFamily="18" charset="0"/>
-                <a:cs typeface="Times New Roman" panose="02020603050405020304" pitchFamily="18" charset="0"/>
-              </a:rPr>
-              <a:t>ovi</a:t>
-            </a:r>
-            <a:r>
-              <a:rPr lang="en-US" sz="1200" dirty="0">
-                <a:latin typeface="Times New Roman" panose="02020603050405020304" pitchFamily="18" charset="0"/>
-                <a:cs typeface="Times New Roman" panose="02020603050405020304" pitchFamily="18" charset="0"/>
-              </a:rPr>
-              <a:t> </a:t>
-            </a:r>
-            <a:r>
-              <a:rPr lang="en-US" sz="1200" dirty="0" err="1">
-                <a:latin typeface="Times New Roman" panose="02020603050405020304" pitchFamily="18" charset="0"/>
-                <a:cs typeface="Times New Roman" panose="02020603050405020304" pitchFamily="18" charset="0"/>
-              </a:rPr>
-              <a:t>faktori</a:t>
-            </a:r>
-            <a:r>
-              <a:rPr lang="en-US" sz="1200" dirty="0">
-                <a:latin typeface="Times New Roman" panose="02020603050405020304" pitchFamily="18" charset="0"/>
-                <a:cs typeface="Times New Roman" panose="02020603050405020304" pitchFamily="18" charset="0"/>
-              </a:rPr>
-              <a:t> </a:t>
-            </a:r>
-            <a:r>
-              <a:rPr lang="en-US" sz="1200" dirty="0" err="1">
-                <a:latin typeface="Times New Roman" panose="02020603050405020304" pitchFamily="18" charset="0"/>
-                <a:cs typeface="Times New Roman" panose="02020603050405020304" pitchFamily="18" charset="0"/>
-              </a:rPr>
-              <a:t>jednako</a:t>
-            </a:r>
-            <a:r>
-              <a:rPr lang="en-US" sz="1200" dirty="0">
-                <a:latin typeface="Times New Roman" panose="02020603050405020304" pitchFamily="18" charset="0"/>
-                <a:cs typeface="Times New Roman" panose="02020603050405020304" pitchFamily="18" charset="0"/>
-              </a:rPr>
-              <a:t> </a:t>
-            </a:r>
-            <a:r>
-              <a:rPr lang="en-US" sz="1200" dirty="0" err="1">
-                <a:latin typeface="Times New Roman" panose="02020603050405020304" pitchFamily="18" charset="0"/>
-                <a:cs typeface="Times New Roman" panose="02020603050405020304" pitchFamily="18" charset="0"/>
-              </a:rPr>
-              <a:t>na</a:t>
-            </a:r>
-            <a:r>
-              <a:rPr lang="en-US" sz="1200" dirty="0">
-                <a:latin typeface="Times New Roman" panose="02020603050405020304" pitchFamily="18" charset="0"/>
-                <a:cs typeface="Times New Roman" panose="02020603050405020304" pitchFamily="18" charset="0"/>
-              </a:rPr>
-              <a:t> </a:t>
-            </a:r>
-            <a:r>
-              <a:rPr lang="en-US" sz="1200" dirty="0" err="1">
-                <a:latin typeface="Times New Roman" panose="02020603050405020304" pitchFamily="18" charset="0"/>
-                <a:cs typeface="Times New Roman" panose="02020603050405020304" pitchFamily="18" charset="0"/>
-              </a:rPr>
-              <a:t>svim</a:t>
-            </a:r>
-            <a:r>
-              <a:rPr lang="en-US" sz="1200" dirty="0">
-                <a:latin typeface="Times New Roman" panose="02020603050405020304" pitchFamily="18" charset="0"/>
-                <a:cs typeface="Times New Roman" panose="02020603050405020304" pitchFamily="18" charset="0"/>
-              </a:rPr>
-              <a:t> </a:t>
-            </a:r>
-            <a:r>
-              <a:rPr lang="en-US" sz="1200" dirty="0" err="1">
-                <a:latin typeface="Times New Roman" panose="02020603050405020304" pitchFamily="18" charset="0"/>
-                <a:cs typeface="Times New Roman" panose="02020603050405020304" pitchFamily="18" charset="0"/>
-              </a:rPr>
-              <a:t>tržištima</a:t>
-            </a:r>
-            <a:r>
-              <a:rPr lang="en-US" sz="1200" dirty="0">
-                <a:latin typeface="Times New Roman" panose="02020603050405020304" pitchFamily="18" charset="0"/>
-                <a:cs typeface="Times New Roman" panose="02020603050405020304" pitchFamily="18" charset="0"/>
-              </a:rPr>
-              <a:t> </a:t>
-            </a:r>
-            <a:r>
-              <a:rPr lang="en-US" sz="1200" dirty="0" err="1">
-                <a:latin typeface="Times New Roman" panose="02020603050405020304" pitchFamily="18" charset="0"/>
-                <a:cs typeface="Times New Roman" panose="02020603050405020304" pitchFamily="18" charset="0"/>
-              </a:rPr>
-              <a:t>ili</a:t>
-            </a:r>
-            <a:r>
-              <a:rPr lang="en-US" sz="1200" dirty="0">
-                <a:latin typeface="Times New Roman" panose="02020603050405020304" pitchFamily="18" charset="0"/>
-                <a:cs typeface="Times New Roman" panose="02020603050405020304" pitchFamily="18" charset="0"/>
-              </a:rPr>
-              <a:t> </a:t>
-            </a:r>
-            <a:r>
-              <a:rPr lang="en-US" sz="1200" dirty="0" err="1">
-                <a:latin typeface="Times New Roman" panose="02020603050405020304" pitchFamily="18" charset="0"/>
-                <a:cs typeface="Times New Roman" panose="02020603050405020304" pitchFamily="18" charset="0"/>
-              </a:rPr>
-              <a:t>postoje</a:t>
-            </a:r>
-            <a:r>
-              <a:rPr lang="en-US" sz="1200" dirty="0">
-                <a:latin typeface="Times New Roman" panose="02020603050405020304" pitchFamily="18" charset="0"/>
-                <a:cs typeface="Times New Roman" panose="02020603050405020304" pitchFamily="18" charset="0"/>
-              </a:rPr>
-              <a:t> </a:t>
-            </a:r>
-            <a:r>
-              <a:rPr lang="en-US" sz="1200" dirty="0" err="1">
-                <a:latin typeface="Times New Roman" panose="02020603050405020304" pitchFamily="18" charset="0"/>
-                <a:cs typeface="Times New Roman" panose="02020603050405020304" pitchFamily="18" charset="0"/>
-              </a:rPr>
-              <a:t>specifični</a:t>
-            </a:r>
-            <a:r>
-              <a:rPr lang="en-US" sz="1200" dirty="0">
-                <a:latin typeface="Times New Roman" panose="02020603050405020304" pitchFamily="18" charset="0"/>
-                <a:cs typeface="Times New Roman" panose="02020603050405020304" pitchFamily="18" charset="0"/>
-              </a:rPr>
-              <a:t> </a:t>
-            </a:r>
-            <a:r>
-              <a:rPr lang="en-US" sz="1200" dirty="0" err="1">
-                <a:latin typeface="Times New Roman" panose="02020603050405020304" pitchFamily="18" charset="0"/>
-                <a:cs typeface="Times New Roman" panose="02020603050405020304" pitchFamily="18" charset="0"/>
-              </a:rPr>
-              <a:t>lokalni</a:t>
-            </a:r>
-            <a:r>
-              <a:rPr lang="en-US" sz="1200" dirty="0">
-                <a:latin typeface="Times New Roman" panose="02020603050405020304" pitchFamily="18" charset="0"/>
-                <a:cs typeface="Times New Roman" panose="02020603050405020304" pitchFamily="18" charset="0"/>
-              </a:rPr>
-              <a:t> </a:t>
-            </a:r>
-            <a:r>
-              <a:rPr lang="en-US" sz="1200" dirty="0" err="1">
-                <a:latin typeface="Times New Roman" panose="02020603050405020304" pitchFamily="18" charset="0"/>
-                <a:cs typeface="Times New Roman" panose="02020603050405020304" pitchFamily="18" charset="0"/>
-              </a:rPr>
-              <a:t>obrasci</a:t>
-            </a:r>
-            <a:r>
-              <a:rPr lang="en-US" sz="1200" dirty="0">
-                <a:latin typeface="Times New Roman" panose="02020603050405020304" pitchFamily="18" charset="0"/>
-                <a:cs typeface="Times New Roman" panose="02020603050405020304" pitchFamily="18" charset="0"/>
-              </a:rPr>
-              <a:t> koji </a:t>
-            </a:r>
-            <a:r>
-              <a:rPr lang="en-US" sz="1200" dirty="0" err="1">
-                <a:latin typeface="Times New Roman" panose="02020603050405020304" pitchFamily="18" charset="0"/>
-                <a:cs typeface="Times New Roman" panose="02020603050405020304" pitchFamily="18" charset="0"/>
-              </a:rPr>
-              <a:t>mijenjaju</a:t>
-            </a:r>
-            <a:r>
-              <a:rPr lang="en-US" sz="1200" dirty="0">
-                <a:latin typeface="Times New Roman" panose="02020603050405020304" pitchFamily="18" charset="0"/>
-                <a:cs typeface="Times New Roman" panose="02020603050405020304" pitchFamily="18" charset="0"/>
-              </a:rPr>
-              <a:t> </a:t>
-            </a:r>
-            <a:r>
-              <a:rPr lang="en-US" sz="1200" dirty="0" err="1">
-                <a:latin typeface="Times New Roman" panose="02020603050405020304" pitchFamily="18" charset="0"/>
-                <a:cs typeface="Times New Roman" panose="02020603050405020304" pitchFamily="18" charset="0"/>
-              </a:rPr>
-              <a:t>njihovu</a:t>
-            </a:r>
-            <a:r>
-              <a:rPr lang="en-US" sz="1200" dirty="0">
-                <a:latin typeface="Times New Roman" panose="02020603050405020304" pitchFamily="18" charset="0"/>
-                <a:cs typeface="Times New Roman" panose="02020603050405020304" pitchFamily="18" charset="0"/>
-              </a:rPr>
-              <a:t> </a:t>
-            </a:r>
-            <a:r>
-              <a:rPr lang="en-US" sz="1200" dirty="0" err="1">
-                <a:latin typeface="Times New Roman" panose="02020603050405020304" pitchFamily="18" charset="0"/>
-                <a:cs typeface="Times New Roman" panose="02020603050405020304" pitchFamily="18" charset="0"/>
-              </a:rPr>
-              <a:t>važnost</a:t>
-            </a:r>
-            <a:r>
-              <a:rPr lang="en-US" sz="1200" dirty="0">
-                <a:latin typeface="Times New Roman" panose="02020603050405020304" pitchFamily="18" charset="0"/>
-                <a:cs typeface="Times New Roman" panose="02020603050405020304" pitchFamily="18" charset="0"/>
-              </a:rPr>
-              <a:t>.</a:t>
-            </a:r>
-            <a:endParaRPr lang="bs-Latn-BA" sz="1200" dirty="0">
+              <a:t>Istraživanje analizira obrasce formiranja cijena Airbnb smještaja u šest mediteranskih i južnoevropskih gradova: Ateni, Malagi, Istanbulu, Napulju, Rimu i Valenciji. Fokus je na dva važna faktora - geografskoj lokaciji smještaja (centar naspram periferije) i tipu smještaja (cijeli stan/kuća, privatna soba i zajednička soba). Cilj rada je utvrditi djeluju li ovi faktori jednako na svim tržištima ili postoje specifični lokalni obrasci koji mijenjaju njihovu važnost.</a:t>
+            </a:r>
+          </a:p>
+          <a:p>
+            <a:pPr algn="just"/>
+            <a:endParaRPr lang="hr-BA" sz="1200" noProof="1">
               <a:latin typeface="Times New Roman" panose="02020603050405020304" pitchFamily="18" charset="0"/>
               <a:cs typeface="Times New Roman" panose="02020603050405020304" pitchFamily="18" charset="0"/>
             </a:endParaRPr>
           </a:p>
           <a:p>
             <a:pPr algn="just"/>
-            <a:endParaRPr lang="bs-Latn-BA" sz="1200" dirty="0">
+            <a:r>
+              <a:rPr lang="hr-BA" sz="1200" noProof="1">
+                <a:latin typeface="Times New Roman" panose="02020603050405020304" pitchFamily="18" charset="0"/>
+                <a:cs typeface="Times New Roman" panose="02020603050405020304" pitchFamily="18" charset="0"/>
+              </a:rPr>
+              <a:t>Analiza je provedena na uzorku od preko 91.000 Airbnb oglasa preuzetih sa platforme Inside Airbnb za period septembar – oktobar 2025. godine. Korištene su metode deskriptivne statistike, geospacijalne analize, regresijskih modela i klasterizacije kako bi se identifikovali dominantni obrasci cijena i razlike između gradova.</a:t>
+            </a:r>
+          </a:p>
+          <a:p>
+            <a:pPr algn="just"/>
+            <a:endParaRPr lang="hr-BA" sz="1200" noProof="1">
               <a:latin typeface="Times New Roman" panose="02020603050405020304" pitchFamily="18" charset="0"/>
               <a:cs typeface="Times New Roman" panose="02020603050405020304" pitchFamily="18" charset="0"/>
             </a:endParaRPr>
@@ -10335,30 +9477,13 @@
           <a:p>
             <a:pPr algn="just"/>
             <a:r>
-              <a:rPr lang="bs-Latn-BA" sz="1200" dirty="0">
+              <a:rPr lang="hr-BA" sz="1200" noProof="1">
                 <a:latin typeface="Times New Roman" panose="02020603050405020304" pitchFamily="18" charset="0"/>
                 <a:cs typeface="Times New Roman" panose="02020603050405020304" pitchFamily="18" charset="0"/>
               </a:rPr>
-              <a:t>Analiza je provedena na uzorku od preko 91.000 Airbnb oglasa preuzetih sa platforme Inside Airbnb za period septembar – oktobar 2025. godine. Korištene su metode deskriptivne statistike, geospacijalne analize, regresijskih modela i klasterizacije kako bi se identifikovali dominantni obrasci cijena i razlike između gradova.</a:t>
-            </a:r>
-          </a:p>
-          <a:p>
-            <a:pPr algn="just"/>
-            <a:endParaRPr lang="bs-Latn-BA" sz="1200" dirty="0">
-              <a:latin typeface="Times New Roman" panose="02020603050405020304" pitchFamily="18" charset="0"/>
-              <a:cs typeface="Times New Roman" panose="02020603050405020304" pitchFamily="18" charset="0"/>
-            </a:endParaRPr>
-          </a:p>
-          <a:p>
-            <a:pPr algn="just"/>
-            <a:r>
-              <a:rPr lang="bs-Latn-BA" sz="1200" dirty="0">
-                <a:latin typeface="Times New Roman" panose="02020603050405020304" pitchFamily="18" charset="0"/>
-                <a:cs typeface="Times New Roman" panose="02020603050405020304" pitchFamily="18" charset="0"/>
-              </a:rPr>
               <a:t>Rezultati pokazuju da tip smještaja u većini gradova ima jači uticaj na cijenu od same lokacije, dok Rim predstavlja izuzetak u kojem su oba faktora podjednako važna. Istraživanje također otktiva da odnos između udaljenost od centra i cijene nije univerzalan, jer pojedini gradovi poput Istanbula i Napulja pokazuju atipične obrasce formiranja cijena.</a:t>
             </a:r>
-            <a:endParaRPr lang="en-US" sz="1000" dirty="0">
+            <a:endParaRPr lang="hr-BA" sz="1000" noProof="1">
               <a:latin typeface="Times New Roman" panose="02020603050405020304" pitchFamily="18" charset="0"/>
               <a:cs typeface="Times New Roman" panose="02020603050405020304" pitchFamily="18" charset="0"/>
             </a:endParaRPr>
@@ -10406,7 +9531,7 @@
           <a:bodyPr/>
           <a:lstStyle/>
           <a:p>
-            <a:endParaRPr lang="en-US"/>
+            <a:endParaRPr lang="hr-BA" noProof="1"/>
           </a:p>
         </p:txBody>
       </p:sp>
@@ -10444,7 +9569,7 @@
           <a:bodyPr/>
           <a:lstStyle/>
           <a:p>
-            <a:endParaRPr lang="en-US"/>
+            <a:endParaRPr lang="hr-BA" noProof="1"/>
           </a:p>
         </p:txBody>
       </p:sp>
@@ -10479,7 +9604,7 @@
               <a:buNone/>
             </a:pPr>
             <a:r>
-              <a:rPr lang="en-US" sz="1400" b="1" dirty="0">
+              <a:rPr lang="hr-BA" sz="1400" b="1" noProof="1">
                 <a:solidFill>
                   <a:srgbClr val="0891B2"/>
                 </a:solidFill>
@@ -10489,7 +9614,7 @@
               </a:rPr>
               <a:t>DATASET &amp; METODOLOGIJA</a:t>
             </a:r>
-            <a:endParaRPr lang="en-US" sz="1400" dirty="0"/>
+            <a:endParaRPr lang="hr-BA" sz="1400" noProof="1"/>
           </a:p>
         </p:txBody>
       </p:sp>
@@ -10525,7 +9650,7 @@
           <a:bodyPr/>
           <a:lstStyle/>
           <a:p>
-            <a:endParaRPr lang="en-US"/>
+            <a:endParaRPr lang="hr-BA" noProof="1"/>
           </a:p>
         </p:txBody>
       </p:sp>
@@ -10558,7 +9683,7 @@
           <a:p>
             <a:pPr algn="just"/>
             <a:r>
-              <a:rPr lang="bs-Latn-BA" sz="1200" dirty="0">
+              <a:rPr lang="hr-BA" sz="1200" noProof="1">
                 <a:latin typeface="Times New Roman" panose="02020603050405020304" pitchFamily="18" charset="0"/>
                 <a:cs typeface="Times New Roman" panose="02020603050405020304" pitchFamily="18" charset="0"/>
               </a:rPr>
@@ -10567,7 +9692,7 @@
           </a:p>
           <a:p>
             <a:pPr algn="just"/>
-            <a:endParaRPr lang="bs-Latn-BA" sz="1200" dirty="0">
+            <a:endParaRPr lang="hr-BA" sz="1200" noProof="1">
               <a:latin typeface="Times New Roman" panose="02020603050405020304" pitchFamily="18" charset="0"/>
               <a:cs typeface="Times New Roman" panose="02020603050405020304" pitchFamily="18" charset="0"/>
             </a:endParaRPr>
@@ -10575,30 +9700,16 @@
           <a:p>
             <a:pPr algn="just"/>
             <a:r>
-              <a:rPr lang="bs-Latn-BA" sz="1200" dirty="0">
+              <a:rPr lang="hr-BA" sz="1200" noProof="1">
                 <a:latin typeface="Times New Roman" panose="02020603050405020304" pitchFamily="18" charset="0"/>
                 <a:cs typeface="Times New Roman" panose="02020603050405020304" pitchFamily="18" charset="0"/>
               </a:rPr>
-              <a:t>Analizirano je 91.301 oglasa iz šest gradova: Atena, Malaga, Istanbul, Napulj, Rim i Valencia. Korišteni su podaci iz listing.csv i </a:t>
-            </a:r>
-            <a:r>
-              <a:rPr lang="en-US" sz="1200" dirty="0" err="1">
-                <a:latin typeface="Times New Roman" panose="02020603050405020304" pitchFamily="18" charset="0"/>
-                <a:cs typeface="Times New Roman" panose="02020603050405020304" pitchFamily="18" charset="0"/>
-              </a:rPr>
-              <a:t>neighbourhoods.geojson</a:t>
-            </a:r>
-            <a:r>
-              <a:rPr lang="bs-Latn-BA" sz="1200" dirty="0">
-                <a:latin typeface="Times New Roman" panose="02020603050405020304" pitchFamily="18" charset="0"/>
-                <a:cs typeface="Times New Roman" panose="02020603050405020304" pitchFamily="18" charset="0"/>
-              </a:rPr>
-              <a:t> datoteka koje sadrže informacije o cijeni, tipu smještaja, lokaciji, recenzijama i kvartovima.</a:t>
+              <a:t>Analizirano je 91.301 oglasa iz šest gradova: Atena, Malaga, Istanbul, Napulj, Rim i Valencia. Korišteni su podaci iz listings.csv i neighbourhoods.geojson datoteka koje sadrže informacije o cijeni, tipu smještaja, lokaciji, recenzijama i kvartovima.</a:t>
             </a:r>
           </a:p>
           <a:p>
             <a:pPr algn="just"/>
-            <a:endParaRPr lang="bs-Latn-BA" sz="1200" dirty="0">
+            <a:endParaRPr lang="hr-BA" sz="1200" noProof="1">
               <a:latin typeface="Times New Roman" panose="02020603050405020304" pitchFamily="18" charset="0"/>
               <a:cs typeface="Times New Roman" panose="02020603050405020304" pitchFamily="18" charset="0"/>
             </a:endParaRPr>
@@ -10606,16 +9717,16 @@
           <a:p>
             <a:pPr algn="just"/>
             <a:r>
-              <a:rPr lang="bs-Latn-BA" sz="1200" dirty="0">
+              <a:rPr lang="hr-BA" sz="1200" noProof="1">
                 <a:latin typeface="Times New Roman" panose="02020603050405020304" pitchFamily="18" charset="0"/>
                 <a:cs typeface="Times New Roman" panose="02020603050405020304" pitchFamily="18" charset="0"/>
               </a:rPr>
-              <a:t>Ključne varijable uključuju cijenu, tip smještaja, lokaciju/kvart, udaljenost od centra, broj recenzija, ocjene gostiju i kapacitet smještaja (accommodates).</a:t>
+              <a:t>Najvažnije varijable uključuju cijenu, tip smještaja, lokaciju/kvart, udaljenost od centra, broj recenzija, ocjene gostiju i kapacitet smještaja (accommodates).</a:t>
             </a:r>
           </a:p>
           <a:p>
             <a:pPr algn="just"/>
-            <a:endParaRPr lang="bs-Latn-BA" sz="1200" dirty="0">
+            <a:endParaRPr lang="hr-BA" sz="1200" noProof="1">
               <a:latin typeface="Times New Roman" panose="02020603050405020304" pitchFamily="18" charset="0"/>
               <a:cs typeface="Times New Roman" panose="02020603050405020304" pitchFamily="18" charset="0"/>
             </a:endParaRPr>
@@ -10623,16 +9734,16 @@
           <a:p>
             <a:pPr algn="just"/>
             <a:r>
-              <a:rPr lang="bs-Latn-BA" sz="1200" dirty="0">
+              <a:rPr lang="hr-BA" sz="1200" noProof="1">
                 <a:latin typeface="Times New Roman" panose="02020603050405020304" pitchFamily="18" charset="0"/>
                 <a:cs typeface="Times New Roman" panose="02020603050405020304" pitchFamily="18" charset="0"/>
               </a:rPr>
-              <a:t>Preprocesiranje podataka obuhvatilo je uklanjanje nedostajućih vrijednosti i outliera (IQR metoda), konverziju valuta u USD, te računanje udaljenosti smještaja od centra grada korištenjem geografskih koordinata.</a:t>
+              <a:t>Preprocesiranje podataka obuhvatilo je uklanjanje nedostajućih vrijednosti i outliera (IQR metoda), konverziju valuta u USD, kao i računanje udaljenosti smještaja od centra grada korištenjem geografskih koordinata.</a:t>
             </a:r>
           </a:p>
           <a:p>
             <a:pPr algn="just"/>
-            <a:endParaRPr lang="bs-Latn-BA" sz="1200" dirty="0">
+            <a:endParaRPr lang="hr-BA" sz="1200" noProof="1">
               <a:latin typeface="Times New Roman" panose="02020603050405020304" pitchFamily="18" charset="0"/>
               <a:cs typeface="Times New Roman" panose="02020603050405020304" pitchFamily="18" charset="0"/>
             </a:endParaRPr>
@@ -10640,16 +9751,12 @@
           <a:p>
             <a:pPr algn="just"/>
             <a:r>
-              <a:rPr lang="bs-Latn-BA" sz="1200" dirty="0">
+              <a:rPr lang="hr-BA" sz="1200" noProof="1">
                 <a:latin typeface="Times New Roman" panose="02020603050405020304" pitchFamily="18" charset="0"/>
                 <a:cs typeface="Times New Roman" panose="02020603050405020304" pitchFamily="18" charset="0"/>
               </a:rPr>
-              <a:t>Metodološki pristup uključuje deskriptivnu statistiku, geospacijalnu analizu, OLS regresiju, korelacijsku analizu i Kmeans klasterizaciju. Vizualizacije su kreirane pomoću biblioteka Matplotlib, Seaborn, Plotly i Folium, dok su za obradu podataka korišteni pandas i NumPy.</a:t>
-            </a:r>
-            <a:endParaRPr lang="en-US" sz="1200" dirty="0">
-              <a:latin typeface="Times New Roman" panose="02020603050405020304" pitchFamily="18" charset="0"/>
-              <a:cs typeface="Times New Roman" panose="02020603050405020304" pitchFamily="18" charset="0"/>
-            </a:endParaRPr>
+              <a:t>Metodološki pristup uključuje deskriptivnu statistiku, geospacijalnu analizu, OLS regresiju, korelacijsku analizu i KMeans klasterizaciju. Vizualizacije su kreirane pomoću biblioteka Matplotlib, Seaborn, Plotly i Folium, dok su za obradu podataka korišteni pandas i NumPy.</a:t>
+            </a:r>
           </a:p>
         </p:txBody>
       </p:sp>
@@ -10694,7 +9801,7 @@
           <a:bodyPr/>
           <a:lstStyle/>
           <a:p>
-            <a:endParaRPr lang="en-US"/>
+            <a:endParaRPr lang="hr-BA" noProof="1"/>
           </a:p>
         </p:txBody>
       </p:sp>
@@ -10732,7 +9839,7 @@
           <a:bodyPr/>
           <a:lstStyle/>
           <a:p>
-            <a:endParaRPr lang="en-US"/>
+            <a:endParaRPr lang="hr-BA" noProof="1"/>
           </a:p>
         </p:txBody>
       </p:sp>
@@ -10767,7 +9874,7 @@
               <a:buNone/>
             </a:pPr>
             <a:r>
-              <a:rPr lang="en-US" sz="1400" b="1" dirty="0">
+              <a:rPr lang="hr-BA" sz="1400" b="1" noProof="1">
                 <a:solidFill>
                   <a:srgbClr val="0891B2"/>
                 </a:solidFill>
@@ -10777,7 +9884,7 @@
               </a:rPr>
               <a:t>VIZUALIZACIJA PODATAKA</a:t>
             </a:r>
-            <a:endParaRPr lang="en-US" sz="1400" dirty="0"/>
+            <a:endParaRPr lang="hr-BA" sz="1400" noProof="1"/>
           </a:p>
         </p:txBody>
       </p:sp>
@@ -10813,7 +9920,7 @@
           <a:bodyPr/>
           <a:lstStyle/>
           <a:p>
-            <a:endParaRPr lang="en-US"/>
+            <a:endParaRPr lang="hr-BA" noProof="1"/>
           </a:p>
         </p:txBody>
       </p:sp>
@@ -10858,7 +9965,7 @@
           <a:bodyPr/>
           <a:lstStyle/>
           <a:p>
-            <a:endParaRPr lang="en-US"/>
+            <a:endParaRPr lang="hr-BA" noProof="1"/>
           </a:p>
         </p:txBody>
       </p:sp>
@@ -10896,7 +10003,7 @@
           <a:bodyPr/>
           <a:lstStyle/>
           <a:p>
-            <a:endParaRPr lang="en-US"/>
+            <a:endParaRPr lang="hr-BA" noProof="1"/>
           </a:p>
         </p:txBody>
       </p:sp>
@@ -10931,7 +10038,7 @@
               <a:buNone/>
             </a:pPr>
             <a:r>
-              <a:rPr lang="en-US" sz="1400" b="1" dirty="0">
+              <a:rPr lang="hr-BA" sz="1400" b="1" noProof="1">
                 <a:solidFill>
                   <a:srgbClr val="1A2E5A"/>
                 </a:solidFill>
@@ -10941,7 +10048,7 @@
               </a:rPr>
               <a:t>ZAKLJUČAK</a:t>
             </a:r>
-            <a:endParaRPr lang="en-US" sz="1400" dirty="0"/>
+            <a:endParaRPr lang="hr-BA" sz="1400" noProof="1"/>
           </a:p>
         </p:txBody>
       </p:sp>
@@ -10977,7 +10084,7 @@
           <a:bodyPr/>
           <a:lstStyle/>
           <a:p>
-            <a:endParaRPr lang="en-US" dirty="0"/>
+            <a:endParaRPr lang="hr-BA" noProof="1"/>
           </a:p>
         </p:txBody>
       </p:sp>
@@ -11010,7 +10117,7 @@
           <a:p>
             <a:pPr algn="just"/>
             <a:r>
-              <a:rPr lang="bs-Latn-BA" sz="1200" dirty="0">
+              <a:rPr lang="hr-BA" sz="1200" noProof="1">
                 <a:latin typeface="Times New Roman" panose="02020603050405020304" pitchFamily="18" charset="0"/>
                 <a:cs typeface="Times New Roman" panose="02020603050405020304" pitchFamily="18" charset="0"/>
               </a:rPr>
@@ -11019,7 +10126,7 @@
           </a:p>
           <a:p>
             <a:pPr algn="just"/>
-            <a:endParaRPr lang="bs-Latn-BA" sz="1200" dirty="0">
+            <a:endParaRPr lang="hr-BA" sz="1200" noProof="1">
               <a:latin typeface="Times New Roman" panose="02020603050405020304" pitchFamily="18" charset="0"/>
               <a:cs typeface="Times New Roman" panose="02020603050405020304" pitchFamily="18" charset="0"/>
             </a:endParaRPr>
@@ -11027,7 +10134,7 @@
           <a:p>
             <a:pPr algn="just"/>
             <a:r>
-              <a:rPr lang="bs-Latn-BA" sz="1200" dirty="0">
+              <a:rPr lang="hr-BA" sz="1200" noProof="1">
                 <a:latin typeface="Times New Roman" panose="02020603050405020304" pitchFamily="18" charset="0"/>
                 <a:cs typeface="Times New Roman" panose="02020603050405020304" pitchFamily="18" charset="0"/>
               </a:rPr>
@@ -11036,7 +10143,7 @@
           </a:p>
           <a:p>
             <a:pPr algn="just"/>
-            <a:endParaRPr lang="bs-Latn-BA" sz="1200" dirty="0">
+            <a:endParaRPr lang="hr-BA" sz="1200" noProof="1">
               <a:latin typeface="Times New Roman" panose="02020603050405020304" pitchFamily="18" charset="0"/>
               <a:cs typeface="Times New Roman" panose="02020603050405020304" pitchFamily="18" charset="0"/>
             </a:endParaRPr>
@@ -11044,7 +10151,7 @@
           <a:p>
             <a:pPr algn="just"/>
             <a:r>
-              <a:rPr lang="bs-Latn-BA" sz="1200" dirty="0">
+              <a:rPr lang="hr-BA" sz="1200" noProof="1">
                 <a:latin typeface="Times New Roman" panose="02020603050405020304" pitchFamily="18" charset="0"/>
                 <a:cs typeface="Times New Roman" panose="02020603050405020304" pitchFamily="18" charset="0"/>
               </a:rPr>
@@ -11053,7 +10160,7 @@
           </a:p>
           <a:p>
             <a:pPr algn="just"/>
-            <a:endParaRPr lang="bs-Latn-BA" sz="1200" dirty="0">
+            <a:endParaRPr lang="hr-BA" sz="1200" noProof="1">
               <a:latin typeface="Times New Roman" panose="02020603050405020304" pitchFamily="18" charset="0"/>
               <a:cs typeface="Times New Roman" panose="02020603050405020304" pitchFamily="18" charset="0"/>
             </a:endParaRPr>
@@ -11061,20 +10168,16 @@
           <a:p>
             <a:pPr algn="just"/>
             <a:r>
-              <a:rPr lang="pl-PL" sz="1200" dirty="0">
+              <a:rPr lang="hr-BA" sz="1200" noProof="1">
                 <a:latin typeface="Times New Roman" panose="02020603050405020304" pitchFamily="18" charset="0"/>
                 <a:cs typeface="Times New Roman" panose="02020603050405020304" pitchFamily="18" charset="0"/>
               </a:rPr>
-              <a:t>Ograničenje: jedan vremenski presjek podataka. Buduća istraživanja mogu uključiti poređenje Airbnb tržišta sa hotelskim sektorom</a:t>
-            </a:r>
-            <a:endParaRPr lang="bs-Latn-BA" sz="1200" dirty="0">
-              <a:latin typeface="Times New Roman" panose="02020603050405020304" pitchFamily="18" charset="0"/>
-              <a:cs typeface="Times New Roman" panose="02020603050405020304" pitchFamily="18" charset="0"/>
-            </a:endParaRPr>
+              <a:t>Ograničenje: jedan vremenski presjek podataka. Buduća istraživanja mogu uključiti poređenje Airbnb tržišta sa hotelskim sektorom.</a:t>
+            </a:r>
           </a:p>
           <a:p>
             <a:pPr algn="just"/>
-            <a:endParaRPr lang="en-US" sz="1200" dirty="0">
+            <a:endParaRPr lang="hr-BA" sz="1200" noProof="1">
               <a:latin typeface="Times New Roman" panose="02020603050405020304" pitchFamily="18" charset="0"/>
               <a:cs typeface="Times New Roman" panose="02020603050405020304" pitchFamily="18" charset="0"/>
             </a:endParaRPr>
@@ -11122,7 +10225,7 @@
           <a:bodyPr/>
           <a:lstStyle/>
           <a:p>
-            <a:endParaRPr lang="en-US"/>
+            <a:endParaRPr lang="hr-BA" noProof="1"/>
           </a:p>
         </p:txBody>
       </p:sp>
@@ -11160,7 +10263,7 @@
           <a:bodyPr/>
           <a:lstStyle/>
           <a:p>
-            <a:endParaRPr lang="en-US"/>
+            <a:endParaRPr lang="hr-BA" noProof="1"/>
           </a:p>
         </p:txBody>
       </p:sp>
@@ -11195,7 +10298,7 @@
               <a:buNone/>
             </a:pPr>
             <a:r>
-              <a:rPr lang="en-US" sz="1400" b="1" dirty="0">
+              <a:rPr lang="hr-BA" sz="1400" b="1" noProof="1">
                 <a:solidFill>
                   <a:srgbClr val="64748B"/>
                 </a:solidFill>
@@ -11205,7 +10308,7 @@
               </a:rPr>
               <a:t>LITERATURA</a:t>
             </a:r>
-            <a:endParaRPr lang="en-US" sz="1400" dirty="0"/>
+            <a:endParaRPr lang="hr-BA" sz="1400" noProof="1"/>
           </a:p>
         </p:txBody>
       </p:sp>
@@ -11241,7 +10344,7 @@
           <a:bodyPr/>
           <a:lstStyle/>
           <a:p>
-            <a:endParaRPr lang="en-US"/>
+            <a:endParaRPr lang="hr-BA" noProof="1"/>
           </a:p>
         </p:txBody>
       </p:sp>
@@ -11273,7 +10376,7 @@
           <a:lstStyle/>
           <a:p>
             <a:r>
-              <a:rPr lang="hr-BA" sz="1200" kern="100" dirty="0">
+              <a:rPr lang="hr-BA" sz="1200" kern="100" noProof="1">
                 <a:latin typeface="Times New Roman" panose="02020603050405020304" pitchFamily="18" charset="0"/>
                 <a:ea typeface="Aptos"/>
                 <a:cs typeface="Times New Roman" panose="02020603050405020304" pitchFamily="18" charset="0"/>
@@ -11281,7 +10384,7 @@
               <a:t>Inside Airbnb. (2025). </a:t>
             </a:r>
             <a:r>
-              <a:rPr lang="hr-BA" sz="1200" i="1" kern="100" dirty="0">
+              <a:rPr lang="hr-BA" sz="1200" i="1" kern="100" noProof="1">
                 <a:latin typeface="Times New Roman" panose="02020603050405020304" pitchFamily="18" charset="0"/>
                 <a:ea typeface="Aptos"/>
                 <a:cs typeface="Times New Roman" panose="02020603050405020304" pitchFamily="18" charset="0"/>
@@ -11289,7 +10392,7 @@
               <a:t>Listings and Neighbourhood Data</a:t>
             </a:r>
             <a:r>
-              <a:rPr lang="hr-BA" sz="1200" kern="100" dirty="0">
+              <a:rPr lang="hr-BA" sz="1200" kern="100" noProof="1">
                 <a:latin typeface="Times New Roman" panose="02020603050405020304" pitchFamily="18" charset="0"/>
                 <a:ea typeface="Aptos"/>
                 <a:cs typeface="Times New Roman" panose="02020603050405020304" pitchFamily="18" charset="0"/>
@@ -11297,7 +10400,7 @@
               <a:t> [Skup podataka za gradove: Atena (26.09.2025.), Malaga (30.09.2025.), Istanbul (29.09.2025.), Napulj (22.09.2025.), Rim (14.09.2025.) i Valencia (23.09.2025.)]. Preuzeto sa zvanične platforme Inside Airbnb: </a:t>
             </a:r>
             <a:r>
-              <a:rPr lang="hr-BA" sz="1200" u="sng" kern="100" dirty="0">
+              <a:rPr lang="hr-BA" sz="1200" u="sng" kern="100" noProof="1">
                 <a:solidFill>
                   <a:srgbClr val="467886"/>
                 </a:solidFill>
@@ -11309,21 +10412,16 @@
               <a:t>https://insideairbnb.com/get-the-data/</a:t>
             </a:r>
             <a:r>
-              <a:rPr lang="hr-BA" sz="1200" kern="100" dirty="0">
+              <a:rPr lang="hr-BA" sz="1200" kern="100" noProof="1">
                 <a:latin typeface="Times New Roman" panose="02020603050405020304" pitchFamily="18" charset="0"/>
                 <a:ea typeface="Aptos"/>
                 <a:cs typeface="Times New Roman" panose="02020603050405020304" pitchFamily="18" charset="0"/>
               </a:rPr>
               <a:t> [Pristupljeno: maj 2026.].</a:t>
             </a:r>
-            <a:endParaRPr lang="bs-Latn-BA" sz="1200" kern="100" dirty="0">
-              <a:latin typeface="Times New Roman" panose="02020603050405020304" pitchFamily="18" charset="0"/>
-              <a:ea typeface="Aptos"/>
-              <a:cs typeface="Times New Roman" panose="02020603050405020304" pitchFamily="18" charset="0"/>
-            </a:endParaRPr>
-          </a:p>
-          <a:p>
-            <a:endParaRPr lang="en-US" sz="1000" dirty="0"/>
+          </a:p>
+          <a:p>
+            <a:endParaRPr lang="hr-BA" sz="1000" noProof="1"/>
           </a:p>
         </p:txBody>
       </p:sp>
@@ -11434,27 +10532,13 @@
           <a:p>
             <a:pPr algn="ctr"/>
             <a:r>
-              <a:rPr lang="bs-Latn-BA" sz="1000" dirty="0">
+              <a:rPr lang="hr-BA" sz="1000" noProof="1">
                 <a:latin typeface="Times New Roman" panose="02020603050405020304" pitchFamily="18" charset="0"/>
                 <a:cs typeface="Times New Roman" panose="02020603050405020304" pitchFamily="18" charset="0"/>
               </a:rPr>
-              <a:t>Slika 1 – Distribucija cijena </a:t>
-            </a:r>
-            <a:r>
-              <a:rPr lang="bs-Latn-BA" sz="1000" dirty="0" err="1">
-                <a:latin typeface="Times New Roman" panose="02020603050405020304" pitchFamily="18" charset="0"/>
-                <a:cs typeface="Times New Roman" panose="02020603050405020304" pitchFamily="18" charset="0"/>
-              </a:rPr>
-              <a:t>Airbnb</a:t>
-            </a:r>
-            <a:r>
-              <a:rPr lang="bs-Latn-BA" sz="1000" dirty="0">
-                <a:latin typeface="Times New Roman" panose="02020603050405020304" pitchFamily="18" charset="0"/>
-                <a:cs typeface="Times New Roman" panose="02020603050405020304" pitchFamily="18" charset="0"/>
-              </a:rPr>
-              <a:t> smještaja po gradu</a:t>
-            </a:r>
-            <a:endParaRPr lang="en-US" sz="700" dirty="0">
+              <a:t>Slika 1 – Distribucija cijena Airbnb smještaja po gradu</a:t>
+            </a:r>
+            <a:endParaRPr lang="hr-BA" sz="700" noProof="1">
               <a:latin typeface="Times New Roman" panose="02020603050405020304" pitchFamily="18" charset="0"/>
               <a:cs typeface="Times New Roman" panose="02020603050405020304" pitchFamily="18" charset="0"/>
             </a:endParaRPr>
@@ -11490,27 +10574,13 @@
           <a:p>
             <a:pPr algn="ctr"/>
             <a:r>
-              <a:rPr lang="bs-Latn-BA" sz="1000" dirty="0">
+              <a:rPr lang="hr-BA" sz="1000" noProof="1">
                 <a:latin typeface="Times New Roman" panose="02020603050405020304" pitchFamily="18" charset="0"/>
                 <a:cs typeface="Times New Roman" panose="02020603050405020304" pitchFamily="18" charset="0"/>
               </a:rPr>
-              <a:t>Slika 2 – Lokacija </a:t>
-            </a:r>
-            <a:r>
-              <a:rPr lang="bs-Latn-BA" sz="1000" dirty="0" err="1">
-                <a:latin typeface="Times New Roman" panose="02020603050405020304" pitchFamily="18" charset="0"/>
-                <a:cs typeface="Times New Roman" panose="02020603050405020304" pitchFamily="18" charset="0"/>
-              </a:rPr>
-              <a:t>vs</a:t>
-            </a:r>
-            <a:r>
-              <a:rPr lang="bs-Latn-BA" sz="1000" dirty="0">
-                <a:latin typeface="Times New Roman" panose="02020603050405020304" pitchFamily="18" charset="0"/>
-                <a:cs typeface="Times New Roman" panose="02020603050405020304" pitchFamily="18" charset="0"/>
-              </a:rPr>
-              <a:t> tip smještaja</a:t>
-            </a:r>
-            <a:endParaRPr lang="en-US" sz="700" dirty="0">
+              <a:t>Slika 2 – Lokacija vs tip smještaja</a:t>
+            </a:r>
+            <a:endParaRPr lang="hr-BA" sz="700" noProof="1">
               <a:latin typeface="Times New Roman" panose="02020603050405020304" pitchFamily="18" charset="0"/>
               <a:cs typeface="Times New Roman" panose="02020603050405020304" pitchFamily="18" charset="0"/>
             </a:endParaRPr>

</xml_diff>